<commit_message>
slides: update image_classifier.pptx to 5-fold CV results with corrected augmentation
- Rewrites all 8 slides to reflect 5-fold stratified CV (was fixed split)
- Updates augmentation slide: fill=[178,178,178], ForegroundColorJitter,
  rotation disabled for Dy28/Dy30 only, translation enabled all days
- Replaces per-day table with kfold OOF numbers (Dy20.5: 0.801, Dy24: 0.853)
- Adds new slide 6 with aug vs no-aug comparison figure
- Updates confusion matrices to OOF aggregated (n=132) predictions
- Updates key findings with corrected average (62.6%) and late-day story
- Regenerates all comparison figures with latest job 1459514 results

Co-Authored-By: Claude Sonnet 4.6 <noreply@anthropic.com>
</commit_message>
<xml_diff>
--- a/figures/image_classifier.pptx
+++ b/figures/image_classifier.pptx
@@ -10,6 +10,7 @@
     <p:sldId id="258" r:id="rId9"/>
     <p:sldId id="259" r:id="rId10"/>
     <p:sldId id="260" r:id="rId11"/>
+    <p:sldId id="264" r:id="rId15"/>
     <p:sldId id="261" r:id="rId12"/>
     <p:sldId id="262" r:id="rId13"/>
     <p:sldId id="263" r:id="rId14"/>
@@ -3209,7 +3210,7 @@
                   <a:srgbClr val="DDEEFF"/>
                 </a:solidFill>
               </a:rPr>
-              <a:t>EfficientNet-B0 · Fixed Train/Val/Test Split · series_idor Cohort</a:t>
+              <a:t>EfficientNet-B0 · 5-Fold Stratified CV · series_idor Cohort</a:t>
             </a:r>
           </a:p>
         </p:txBody>
@@ -3243,10 +3244,29 @@
                   <a:srgbClr val="CCDDEE"/>
                 </a:solidFill>
               </a:rPr>
-              <a:t>Architecture:  EfficientNet-B0 (ImageNet pretrained) → 128-dim → binary logit
-Input:         cm_source_image  (mean-filled background, 384×512 px)
-Cohort:        series_idor  (132 organoids, edge_fraction ≤ 0.05 every day)
-Split:         70 / 10 / 20 % stratified (fixed seed)</a:t>
+              <a:t>Architecture:  EfficientNet-B0 (ImageNet pretrained) → 128-dim → binary logit</a:t>
+            </a:r>
+          </a:p>
+          <a:p>
+            <a:pPr algn="l"/>
+            <a:r>
+              <a:rPr b="0" sz="1500">
+                <a:solidFill>
+                  <a:srgbClr val="CCDDEE"/>
+                </a:solidFill>
+              </a:rPr>
+              <a:t>Input:         cm_image_abs  (mean-filled background, [178,178,178])</a:t>
+            </a:r>
+          </a:p>
+          <a:p>
+            <a:pPr algn="l"/>
+            <a:r>
+              <a:rPr b="0" sz="1500">
+                <a:solidFill>
+                  <a:srgbClr val="CCDDEE"/>
+                </a:solidFill>
+              </a:rPr>
+              <a:t>Evaluation:    5-fold stratified CV, organoid-level; OOF balanced accuracy reported</a:t>
             </a:r>
           </a:p>
         </p:txBody>
@@ -5711,7 +5731,7 @@
                   <a:srgbClr val="FFFFFF"/>
                 </a:solidFill>
               </a:rPr>
-              <a:t>RandomAffine(degrees=180, translate=(±10%), fill=ImageNet-mean)</a:t>
+              <a:t>RandomAffine(degrees=180, translate=(±10%), fill=[178, 178, 178])</a:t>
             </a:r>
           </a:p>
         </p:txBody>
@@ -5745,9 +5765,29 @@
                   <a:srgbClr val="444444"/>
                 </a:solidFill>
               </a:rPr>
-              <a:t>Single interpolation pass for rotation + translation.
-Fill colour = [123, 116, 103] (ImageNet mean) matches the background,
-so revealed areas blend with the mean-filled background.</a:t>
+              <a:t>Single interpolation pass for rotation + translation.</a:t>
+            </a:r>
+          </a:p>
+          <a:p>
+            <a:pPr algn="l"/>
+            <a:r>
+              <a:rPr b="0" sz="1300">
+                <a:solidFill>
+                  <a:srgbClr val="444444"/>
+                </a:solidFill>
+              </a:rPr>
+              <a:t>Fill colour = [178, 178, 178] matches cm_image_abs background (verified from data).</a:t>
+            </a:r>
+          </a:p>
+          <a:p>
+            <a:pPr algn="l"/>
+            <a:r>
+              <a:rPr b="0" sz="1300">
+                <a:solidFill>
+                  <a:srgbClr val="444444"/>
+                </a:solidFill>
+              </a:rPr>
+              <a:t>Translation ±10% enabled for ALL days (post-resize margin ≥113 px at Dy28/Dy30).</a:t>
             </a:r>
           </a:p>
         </p:txBody>
@@ -5824,7 +5864,7 @@
                   <a:srgbClr val="FFFFFF"/>
                 </a:solidFill>
               </a:rPr>
-              <a:t>ColorJitter(brightness=0.3, contrast=0.3, saturation=0.2, hue=0.05)</a:t>
+              <a:t>ForegroundColorJitter(brightness=0.3, contrast=0.3, saturation=0.2, hue=0.05)</a:t>
             </a:r>
           </a:p>
         </p:txBody>
@@ -5858,8 +5898,18 @@
                   <a:srgbClr val="444444"/>
                 </a:solidFill>
               </a:rPr>
-              <a:t>Intensity/contrast jitter for photometric robustness.
-Hue kept small: mean-filled background is achromatic and doesn't shift with hue.</a:t>
+              <a:t>Applies ColorJitter to organoid pixels only; background mask ([178,178,178] ±3) is</a:t>
+            </a:r>
+          </a:p>
+          <a:p>
+            <a:pPr algn="l"/>
+            <a:r>
+              <a:rPr b="0" sz="1300">
+                <a:solidFill>
+                  <a:srgbClr val="444444"/>
+                </a:solidFill>
+              </a:rPr>
+              <a:t>saved before and restored after jitter — background never changes colour.</a:t>
             </a:r>
           </a:p>
         </p:txBody>
@@ -5936,7 +5986,7 @@
                   <a:srgbClr val="FFFFFF"/>
                 </a:solidFill>
               </a:rPr>
-              <a:t>Translation disabled for Dy28 / Dy30</a:t>
+              <a:t>Rotation disabled for Dy28 / Dy30</a:t>
             </a:r>
           </a:p>
         </p:txBody>
@@ -5970,8 +6020,18 @@
                   <a:srgbClr val="444444"/>
                 </a:solidFill>
               </a:rPr>
-              <a:t>At late days, large organoids may touch the image boundary.
-Translation would shift boundary-clipped cells — disabled for these days.</a:t>
+              <a:t>At late days, organoid fills most of the frame; full ±180° rotation risks clipping it</a:t>
+            </a:r>
+          </a:p>
+          <a:p>
+            <a:pPr algn="l"/>
+            <a:r>
+              <a:rPr b="0" sz="1300">
+                <a:solidFill>
+                  <a:srgbClr val="444444"/>
+                </a:solidFill>
+              </a:rPr>
+              <a:t>in the 384×512 (non-square) frame.  H-flip and translation remain active.</a:t>
             </a:r>
           </a:p>
         </p:txBody>
@@ -6108,7 +6168,7 @@
                   <a:srgbClr val="AACCFF"/>
                 </a:solidFill>
               </a:rPr>
-              <a:t>series_idor cohort — fixed stratified split</a:t>
+              <a:t>series_idor cohort — 5-fold stratified CV</a:t>
             </a:r>
           </a:p>
         </p:txBody>
@@ -6690,7 +6750,7 @@
                   <a:srgbClr val="444444"/>
                 </a:solidFill>
               </a:rPr>
-              <a:t>Train</a:t>
+              <a:t>CV scheme</a:t>
             </a:r>
           </a:p>
         </p:txBody>
@@ -6724,7 +6784,7 @@
                   <a:srgbClr val="444444"/>
                 </a:solidFill>
               </a:rPr>
-              <a:t>95 organoids  (15 Not Acceptable, 80 Acceptable)</a:t>
+              <a:t>StratifiedKFold(n_splits=5, seed=1), organoid-level stratification</a:t>
             </a:r>
           </a:p>
         </p:txBody>
@@ -6844,7 +6904,7 @@
                   <a:srgbClr val="444444"/>
                 </a:solidFill>
               </a:rPr>
-              <a:t>Val</a:t>
+              <a:t>Per-fold split</a:t>
             </a:r>
           </a:p>
         </p:txBody>
@@ -6878,7 +6938,7 @@
                   <a:srgbClr val="444444"/>
                 </a:solidFill>
               </a:rPr>
-              <a:t>10 organoids</a:t>
+              <a:t>~105 train / ~16 val (15% of train) / ~26 OOF test organoids</a:t>
             </a:r>
           </a:p>
         </p:txBody>
@@ -6998,7 +7058,7 @@
                   <a:srgbClr val="444444"/>
                 </a:solidFill>
               </a:rPr>
-              <a:t>Test</a:t>
+              <a:t>OOF test</a:t>
             </a:r>
           </a:p>
         </p:txBody>
@@ -7032,7 +7092,7 @@
                   <a:srgbClr val="444444"/>
                 </a:solidFill>
               </a:rPr>
-              <a:t>27 organoids  (5 Not Acceptable, 22 Acceptable)</a:t>
+              <a:t>132 organoids total (all 5 folds combined)</a:t>
             </a:r>
           </a:p>
         </p:txBody>
@@ -7186,7 +7246,7 @@
                   <a:srgbClr val="444444"/>
                 </a:solidFill>
               </a:rPr>
-              <a:t>cm_source_image  — segmentation-masked, background mean-filled</a:t>
+              <a:t>cm_image_abs  — segmentation-masked, background mean-filled [178,178,178]</a:t>
             </a:r>
           </a:p>
         </p:txBody>
@@ -7460,7 +7520,7 @@
                   <a:srgbClr val="444444"/>
                 </a:solidFill>
               </a:rPr>
-              <a:t>Same split</a:t>
+              <a:t>Independence</a:t>
             </a:r>
           </a:p>
         </p:txBody>
@@ -7494,7 +7554,7 @@
                   <a:srgbClr val="444444"/>
                 </a:solidFill>
               </a:rPr>
-              <a:t>All 11 days trained with identical organoid split</a:t>
+              <a:t>Independent model trained per day; same CV splits for all 11 days</a:t>
             </a:r>
           </a:p>
         </p:txBody>
@@ -7528,7 +7588,7 @@
                   <a:srgbClr val="888888"/>
                 </a:solidFill>
               </a:rPr>
-              <a:t>Note: label is per-organoid (not per-day). The same train/val/test organoids appear at all 11 days — each day trains a separate model on the same cohort split using that day's images.</a:t>
+              <a:t>Note: label is per-organoid (same label across all days). BalAcc reported as mean ± std across 5 folds AND from OOF aggregated predictions.</a:t>
             </a:r>
           </a:p>
         </p:txBody>
@@ -7665,21 +7725,21 @@
                   <a:srgbClr val="AACCFF"/>
                 </a:solidFill>
               </a:rPr>
-              <a:t>EfficientNet-B0 · series_idor cohort · fixed split</a:t>
+              <a:t>EfficientNet-B0 · series_idor cohort · 5-fold CV  (mean ±1 SD shading)</a:t>
             </a:r>
           </a:p>
         </p:txBody>
       </p:sp>
       <p:pic>
         <p:nvPicPr>
-          <p:cNvPr id="5" name="Picture 4" descr="perday_image_balanced_accuracy.png"/>
+          <p:cNvPr id="5" name="Picture 4" descr="image.png"/>
           <p:cNvPicPr>
             <a:picLocks noChangeAspect="1"/>
           </p:cNvPicPr>
           <p:nvPr/>
         </p:nvPicPr>
         <p:blipFill>
-          <a:blip r:embed="rId2"/>
+          <a:blip r:embed="rId3"/>
           <a:stretch>
             <a:fillRect/>
           </a:stretch>
@@ -7826,7 +7886,7 @@
                   <a:srgbClr val="AACCFF"/>
                 </a:solidFill>
               </a:rPr>
-              <a:t>EfficientNet-B0 · series_idor · test set (n=27)</a:t>
+              <a:t>EfficientNet-B0 · series_idor · OOF (n=132), balanced accuracy mean ± std</a:t>
             </a:r>
           </a:p>
         </p:txBody>
@@ -7983,6 +8043,17 @@
               <a:t>BalAcc</a:t>
             </a:r>
           </a:p>
+          <a:p>
+            <a:pPr algn="ctr"/>
+            <a:r>
+              <a:rPr b="1" sz="1100">
+                <a:solidFill>
+                  <a:srgbClr val="FFFFFF"/>
+                </a:solidFill>
+              </a:rPr>
+              <a:t>(mean±std)</a:t>
+            </a:r>
+          </a:p>
         </p:txBody>
       </p:sp>
       <p:sp>
@@ -8752,7 +8823,7 @@
                   <a:srgbClr val="444444"/>
                 </a:solidFill>
               </a:rPr>
-              <a:t>0.500</a:t>
+              <a:t>0.511±0.022</a:t>
             </a:r>
           </a:p>
         </p:txBody>
@@ -8829,7 +8900,7 @@
                   <a:srgbClr val="444444"/>
                 </a:solidFill>
               </a:rPr>
-              <a:t>0.000</a:t>
+              <a:t>0.045</a:t>
             </a:r>
           </a:p>
         </p:txBody>
@@ -8906,7 +8977,7 @@
                   <a:srgbClr val="444444"/>
                 </a:solidFill>
               </a:rPr>
-              <a:t>1.000</a:t>
+              <a:t>0.982</a:t>
             </a:r>
           </a:p>
         </p:txBody>
@@ -8983,7 +9054,7 @@
                   <a:srgbClr val="444444"/>
                 </a:solidFill>
               </a:rPr>
-              <a:t>0.815</a:t>
+              <a:t>0.826</a:t>
             </a:r>
           </a:p>
         </p:txBody>
@@ -9060,7 +9131,7 @@
                   <a:srgbClr val="444444"/>
                 </a:solidFill>
               </a:rPr>
-              <a:t>0.373</a:t>
+              <a:t>0.468</a:t>
             </a:r>
           </a:p>
         </p:txBody>
@@ -9137,7 +9208,7 @@
                   <a:srgbClr val="444444"/>
                 </a:solidFill>
               </a:rPr>
-              <a:t>22</a:t>
+              <a:t>108</a:t>
             </a:r>
           </a:p>
         </p:txBody>
@@ -9214,7 +9285,7 @@
                   <a:srgbClr val="444444"/>
                 </a:solidFill>
               </a:rPr>
-              <a:t>0</a:t>
+              <a:t>2</a:t>
             </a:r>
           </a:p>
         </p:txBody>
@@ -9291,7 +9362,7 @@
                   <a:srgbClr val="444444"/>
                 </a:solidFill>
               </a:rPr>
-              <a:t>5</a:t>
+              <a:t>21</a:t>
             </a:r>
           </a:p>
         </p:txBody>
@@ -9368,7 +9439,7 @@
                   <a:srgbClr val="444444"/>
                 </a:solidFill>
               </a:rPr>
-              <a:t>0</a:t>
+              <a:t>1</a:t>
             </a:r>
           </a:p>
         </p:txBody>
@@ -9522,7 +9593,7 @@
                   <a:srgbClr val="444444"/>
                 </a:solidFill>
               </a:rPr>
-              <a:t>0.500</a:t>
+              <a:t>0.500±0.000</a:t>
             </a:r>
           </a:p>
         </p:txBody>
@@ -9753,7 +9824,7 @@
                   <a:srgbClr val="444444"/>
                 </a:solidFill>
               </a:rPr>
-              <a:t>0.815</a:t>
+              <a:t>0.833</a:t>
             </a:r>
           </a:p>
         </p:txBody>
@@ -9830,7 +9901,7 @@
                   <a:srgbClr val="444444"/>
                 </a:solidFill>
               </a:rPr>
-              <a:t>0.727</a:t>
+              <a:t>0.530</a:t>
             </a:r>
           </a:p>
         </p:txBody>
@@ -9907,7 +9978,7 @@
                   <a:srgbClr val="444444"/>
                 </a:solidFill>
               </a:rPr>
-              <a:t>22</a:t>
+              <a:t>110</a:t>
             </a:r>
           </a:p>
         </p:txBody>
@@ -10061,7 +10132,7 @@
                   <a:srgbClr val="444444"/>
                 </a:solidFill>
               </a:rPr>
-              <a:t>5</a:t>
+              <a:t>22</a:t>
             </a:r>
           </a:p>
         </p:txBody>
@@ -10292,7 +10363,7 @@
                   <a:srgbClr val="444444"/>
                 </a:solidFill>
               </a:rPr>
-              <a:t>0.500</a:t>
+              <a:t>0.500±0.000</a:t>
             </a:r>
           </a:p>
         </p:txBody>
@@ -10523,7 +10594,7 @@
                   <a:srgbClr val="444444"/>
                 </a:solidFill>
               </a:rPr>
-              <a:t>0.815</a:t>
+              <a:t>0.833</a:t>
             </a:r>
           </a:p>
         </p:txBody>
@@ -10600,7 +10671,7 @@
                   <a:srgbClr val="444444"/>
                 </a:solidFill>
               </a:rPr>
-              <a:t>0.345</a:t>
+              <a:t>0.469</a:t>
             </a:r>
           </a:p>
         </p:txBody>
@@ -10677,7 +10748,7 @@
                   <a:srgbClr val="444444"/>
                 </a:solidFill>
               </a:rPr>
-              <a:t>22</a:t>
+              <a:t>110</a:t>
             </a:r>
           </a:p>
         </p:txBody>
@@ -10831,7 +10902,7 @@
                   <a:srgbClr val="444444"/>
                 </a:solidFill>
               </a:rPr>
-              <a:t>5</a:t>
+              <a:t>22</a:t>
             </a:r>
           </a:p>
         </p:txBody>
@@ -11062,7 +11133,7 @@
                   <a:srgbClr val="444444"/>
                 </a:solidFill>
               </a:rPr>
-              <a:t>0.500</a:t>
+              <a:t>0.491±0.018</a:t>
             </a:r>
           </a:p>
         </p:txBody>
@@ -11216,7 +11287,7 @@
                   <a:srgbClr val="444444"/>
                 </a:solidFill>
               </a:rPr>
-              <a:t>1.000</a:t>
+              <a:t>0.982</a:t>
             </a:r>
           </a:p>
         </p:txBody>
@@ -11293,7 +11364,7 @@
                   <a:srgbClr val="444444"/>
                 </a:solidFill>
               </a:rPr>
-              <a:t>0.815</a:t>
+              <a:t>0.818</a:t>
             </a:r>
           </a:p>
         </p:txBody>
@@ -11370,7 +11441,7 @@
                   <a:srgbClr val="444444"/>
                 </a:solidFill>
               </a:rPr>
-              <a:t>0.582</a:t>
+              <a:t>0.432</a:t>
             </a:r>
           </a:p>
         </p:txBody>
@@ -11447,7 +11518,7 @@
                   <a:srgbClr val="444444"/>
                 </a:solidFill>
               </a:rPr>
-              <a:t>22</a:t>
+              <a:t>108</a:t>
             </a:r>
           </a:p>
         </p:txBody>
@@ -11524,7 +11595,7 @@
                   <a:srgbClr val="444444"/>
                 </a:solidFill>
               </a:rPr>
-              <a:t>0</a:t>
+              <a:t>2</a:t>
             </a:r>
           </a:p>
         </p:txBody>
@@ -11601,7 +11672,7 @@
                   <a:srgbClr val="444444"/>
                 </a:solidFill>
               </a:rPr>
-              <a:t>5</a:t>
+              <a:t>22</a:t>
             </a:r>
           </a:p>
         </p:txBody>
@@ -11832,7 +11903,7 @@
                   <a:srgbClr val="444444"/>
                 </a:solidFill>
               </a:rPr>
-              <a:t>0.500</a:t>
+              <a:t>0.500±0.000</a:t>
             </a:r>
           </a:p>
         </p:txBody>
@@ -12063,7 +12134,7 @@
                   <a:srgbClr val="444444"/>
                 </a:solidFill>
               </a:rPr>
-              <a:t>0.815</a:t>
+              <a:t>0.833</a:t>
             </a:r>
           </a:p>
         </p:txBody>
@@ -12140,7 +12211,7 @@
                   <a:srgbClr val="444444"/>
                 </a:solidFill>
               </a:rPr>
-              <a:t>0.409</a:t>
+              <a:t>0.498</a:t>
             </a:r>
           </a:p>
         </p:txBody>
@@ -12217,7 +12288,7 @@
                   <a:srgbClr val="444444"/>
                 </a:solidFill>
               </a:rPr>
-              <a:t>22</a:t>
+              <a:t>110</a:t>
             </a:r>
           </a:p>
         </p:txBody>
@@ -12371,7 +12442,7 @@
                   <a:srgbClr val="444444"/>
                 </a:solidFill>
               </a:rPr>
-              <a:t>5</a:t>
+              <a:t>22</a:t>
             </a:r>
           </a:p>
         </p:txBody>
@@ -12602,7 +12673,7 @@
                   <a:srgbClr val="444444"/>
                 </a:solidFill>
               </a:rPr>
-              <a:t>0.500</a:t>
+              <a:t>0.545±0.103</a:t>
             </a:r>
           </a:p>
         </p:txBody>
@@ -12679,7 +12750,7 @@
                   <a:srgbClr val="444444"/>
                 </a:solidFill>
               </a:rPr>
-              <a:t>0.000</a:t>
+              <a:t>0.091</a:t>
             </a:r>
           </a:p>
         </p:txBody>
@@ -12756,7 +12827,7 @@
                   <a:srgbClr val="444444"/>
                 </a:solidFill>
               </a:rPr>
-              <a:t>1.000</a:t>
+              <a:t>0.991</a:t>
             </a:r>
           </a:p>
         </p:txBody>
@@ -12833,7 +12904,7 @@
                   <a:srgbClr val="444444"/>
                 </a:solidFill>
               </a:rPr>
-              <a:t>0.815</a:t>
+              <a:t>0.841</a:t>
             </a:r>
           </a:p>
         </p:txBody>
@@ -12910,7 +12981,7 @@
                   <a:srgbClr val="444444"/>
                 </a:solidFill>
               </a:rPr>
-              <a:t>0.645</a:t>
+              <a:t>0.565</a:t>
             </a:r>
           </a:p>
         </p:txBody>
@@ -12987,7 +13058,7 @@
                   <a:srgbClr val="444444"/>
                 </a:solidFill>
               </a:rPr>
-              <a:t>22</a:t>
+              <a:t>109</a:t>
             </a:r>
           </a:p>
         </p:txBody>
@@ -13064,7 +13135,7 @@
                   <a:srgbClr val="444444"/>
                 </a:solidFill>
               </a:rPr>
-              <a:t>0</a:t>
+              <a:t>1</a:t>
             </a:r>
           </a:p>
         </p:txBody>
@@ -13141,7 +13212,7 @@
                   <a:srgbClr val="444444"/>
                 </a:solidFill>
               </a:rPr>
-              <a:t>5</a:t>
+              <a:t>20</a:t>
             </a:r>
           </a:p>
         </p:txBody>
@@ -13218,7 +13289,7 @@
                   <a:srgbClr val="444444"/>
                 </a:solidFill>
               </a:rPr>
-              <a:t>0</a:t>
+              <a:t>2</a:t>
             </a:r>
           </a:p>
         </p:txBody>
@@ -13372,7 +13443,7 @@
                   <a:srgbClr val="444444"/>
                 </a:solidFill>
               </a:rPr>
-              <a:t>0.577</a:t>
+              <a:t>0.607±0.113</a:t>
             </a:r>
           </a:p>
         </p:txBody>
@@ -13449,7 +13520,7 @@
                   <a:srgbClr val="444444"/>
                 </a:solidFill>
               </a:rPr>
-              <a:t>0.200</a:t>
+              <a:t>0.273</a:t>
             </a:r>
           </a:p>
         </p:txBody>
@@ -13603,7 +13674,7 @@
                   <a:srgbClr val="444444"/>
                 </a:solidFill>
               </a:rPr>
-              <a:t>0.815</a:t>
+              <a:t>0.841</a:t>
             </a:r>
           </a:p>
         </p:txBody>
@@ -13680,7 +13751,7 @@
                   <a:srgbClr val="444444"/>
                 </a:solidFill>
               </a:rPr>
-              <a:t>0.591</a:t>
+              <a:t>0.713</a:t>
             </a:r>
           </a:p>
         </p:txBody>
@@ -13757,7 +13828,7 @@
                   <a:srgbClr val="444444"/>
                 </a:solidFill>
               </a:rPr>
-              <a:t>21</a:t>
+              <a:t>105</a:t>
             </a:r>
           </a:p>
         </p:txBody>
@@ -13834,7 +13905,7 @@
                   <a:srgbClr val="444444"/>
                 </a:solidFill>
               </a:rPr>
-              <a:t>1</a:t>
+              <a:t>5</a:t>
             </a:r>
           </a:p>
         </p:txBody>
@@ -13911,7 +13982,7 @@
                   <a:srgbClr val="444444"/>
                 </a:solidFill>
               </a:rPr>
-              <a:t>4</a:t>
+              <a:t>16</a:t>
             </a:r>
           </a:p>
         </p:txBody>
@@ -13988,7 +14059,7 @@
                   <a:srgbClr val="444444"/>
                 </a:solidFill>
               </a:rPr>
-              <a:t>1</a:t>
+              <a:t>6</a:t>
             </a:r>
           </a:p>
         </p:txBody>
@@ -14142,7 +14213,7 @@
                   <a:srgbClr val="444444"/>
                 </a:solidFill>
               </a:rPr>
-              <a:t>0.600</a:t>
+              <a:t>0.801±0.068</a:t>
             </a:r>
           </a:p>
         </p:txBody>
@@ -14219,7 +14290,7 @@
                   <a:srgbClr val="444444"/>
                 </a:solidFill>
               </a:rPr>
-              <a:t>0.200</a:t>
+              <a:t>0.636</a:t>
             </a:r>
           </a:p>
         </p:txBody>
@@ -14296,7 +14367,7 @@
                   <a:srgbClr val="444444"/>
                 </a:solidFill>
               </a:rPr>
-              <a:t>1.000</a:t>
+              <a:t>0.973</a:t>
             </a:r>
           </a:p>
         </p:txBody>
@@ -14373,7 +14444,7 @@
                   <a:srgbClr val="444444"/>
                 </a:solidFill>
               </a:rPr>
-              <a:t>0.852</a:t>
+              <a:t>0.917</a:t>
             </a:r>
           </a:p>
         </p:txBody>
@@ -14450,7 +14521,7 @@
                   <a:srgbClr val="444444"/>
                 </a:solidFill>
               </a:rPr>
-              <a:t>0.855</a:t>
+              <a:t>0.845</a:t>
             </a:r>
           </a:p>
         </p:txBody>
@@ -14527,7 +14598,7 @@
                   <a:srgbClr val="444444"/>
                 </a:solidFill>
               </a:rPr>
-              <a:t>22</a:t>
+              <a:t>107</a:t>
             </a:r>
           </a:p>
         </p:txBody>
@@ -14604,7 +14675,7 @@
                   <a:srgbClr val="444444"/>
                 </a:solidFill>
               </a:rPr>
-              <a:t>0</a:t>
+              <a:t>3</a:t>
             </a:r>
           </a:p>
         </p:txBody>
@@ -14681,7 +14752,7 @@
                   <a:srgbClr val="444444"/>
                 </a:solidFill>
               </a:rPr>
-              <a:t>4</a:t>
+              <a:t>8</a:t>
             </a:r>
           </a:p>
         </p:txBody>
@@ -14758,7 +14829,7 @@
                   <a:srgbClr val="444444"/>
                 </a:solidFill>
               </a:rPr>
-              <a:t>1</a:t>
+              <a:t>14</a:t>
             </a:r>
           </a:p>
         </p:txBody>
@@ -14912,7 +14983,7 @@
                   <a:srgbClr val="444444"/>
                 </a:solidFill>
               </a:rPr>
-              <a:t>0.800</a:t>
+              <a:t>0.853±0.087</a:t>
             </a:r>
           </a:p>
         </p:txBody>
@@ -14989,7 +15060,7 @@
                   <a:srgbClr val="444444"/>
                 </a:solidFill>
               </a:rPr>
-              <a:t>0.600</a:t>
+              <a:t>0.773</a:t>
             </a:r>
           </a:p>
         </p:txBody>
@@ -15066,7 +15137,7 @@
                   <a:srgbClr val="444444"/>
                 </a:solidFill>
               </a:rPr>
-              <a:t>1.000</a:t>
+              <a:t>0.936</a:t>
             </a:r>
           </a:p>
         </p:txBody>
@@ -15143,7 +15214,7 @@
                   <a:srgbClr val="444444"/>
                 </a:solidFill>
               </a:rPr>
-              <a:t>0.926</a:t>
+              <a:t>0.909</a:t>
             </a:r>
           </a:p>
         </p:txBody>
@@ -15220,7 +15291,7 @@
                   <a:srgbClr val="444444"/>
                 </a:solidFill>
               </a:rPr>
-              <a:t>0.873</a:t>
+              <a:t>0.872</a:t>
             </a:r>
           </a:p>
         </p:txBody>
@@ -15297,7 +15368,7 @@
                   <a:srgbClr val="444444"/>
                 </a:solidFill>
               </a:rPr>
-              <a:t>22</a:t>
+              <a:t>103</a:t>
             </a:r>
           </a:p>
         </p:txBody>
@@ -15374,7 +15445,7 @@
                   <a:srgbClr val="444444"/>
                 </a:solidFill>
               </a:rPr>
-              <a:t>0</a:t>
+              <a:t>7</a:t>
             </a:r>
           </a:p>
         </p:txBody>
@@ -15451,7 +15522,7 @@
                   <a:srgbClr val="444444"/>
                 </a:solidFill>
               </a:rPr>
-              <a:t>2</a:t>
+              <a:t>5</a:t>
             </a:r>
           </a:p>
         </p:txBody>
@@ -15528,7 +15599,7 @@
                   <a:srgbClr val="444444"/>
                 </a:solidFill>
               </a:rPr>
-              <a:t>3</a:t>
+              <a:t>17</a:t>
             </a:r>
           </a:p>
         </p:txBody>
@@ -15682,7 +15753,7 @@
                   <a:srgbClr val="444444"/>
                 </a:solidFill>
               </a:rPr>
-              <a:t>0.877</a:t>
+              <a:t>0.740±0.132</a:t>
             </a:r>
           </a:p>
         </p:txBody>
@@ -15759,7 +15830,7 @@
                   <a:srgbClr val="444444"/>
                 </a:solidFill>
               </a:rPr>
-              <a:t>0.800</a:t>
+              <a:t>0.500</a:t>
             </a:r>
           </a:p>
         </p:txBody>
@@ -15836,7 +15907,7 @@
                   <a:srgbClr val="444444"/>
                 </a:solidFill>
               </a:rPr>
-              <a:t>0.955</a:t>
+              <a:t>1.000</a:t>
             </a:r>
           </a:p>
         </p:txBody>
@@ -15913,7 +15984,7 @@
                   <a:srgbClr val="444444"/>
                 </a:solidFill>
               </a:rPr>
-              <a:t>0.926</a:t>
+              <a:t>0.917</a:t>
             </a:r>
           </a:p>
         </p:txBody>
@@ -15990,7 +16061,7 @@
                   <a:srgbClr val="444444"/>
                 </a:solidFill>
               </a:rPr>
-              <a:t>0.873</a:t>
+              <a:t>0.862</a:t>
             </a:r>
           </a:p>
         </p:txBody>
@@ -16067,7 +16138,7 @@
                   <a:srgbClr val="444444"/>
                 </a:solidFill>
               </a:rPr>
-              <a:t>21</a:t>
+              <a:t>110</a:t>
             </a:r>
           </a:p>
         </p:txBody>
@@ -16144,7 +16215,7 @@
                   <a:srgbClr val="444444"/>
                 </a:solidFill>
               </a:rPr>
-              <a:t>1</a:t>
+              <a:t>0</a:t>
             </a:r>
           </a:p>
         </p:txBody>
@@ -16221,7 +16292,7 @@
                   <a:srgbClr val="444444"/>
                 </a:solidFill>
               </a:rPr>
-              <a:t>1</a:t>
+              <a:t>11</a:t>
             </a:r>
           </a:p>
         </p:txBody>
@@ -16298,7 +16369,7 @@
                   <a:srgbClr val="444444"/>
                 </a:solidFill>
               </a:rPr>
-              <a:t>4</a:t>
+              <a:t>11</a:t>
             </a:r>
           </a:p>
         </p:txBody>
@@ -16452,7 +16523,7 @@
                   <a:srgbClr val="444444"/>
                 </a:solidFill>
               </a:rPr>
-              <a:t>0.800</a:t>
+              <a:t>0.840±0.097</a:t>
             </a:r>
           </a:p>
         </p:txBody>
@@ -16529,7 +16600,7 @@
                   <a:srgbClr val="444444"/>
                 </a:solidFill>
               </a:rPr>
-              <a:t>0.600</a:t>
+              <a:t>0.682</a:t>
             </a:r>
           </a:p>
         </p:txBody>
@@ -16683,7 +16754,7 @@
                   <a:srgbClr val="444444"/>
                 </a:solidFill>
               </a:rPr>
-              <a:t>0.926</a:t>
+              <a:t>0.947</a:t>
             </a:r>
           </a:p>
         </p:txBody>
@@ -16760,7 +16831,7 @@
                   <a:srgbClr val="444444"/>
                 </a:solidFill>
               </a:rPr>
-              <a:t>0.918</a:t>
+              <a:t>0.911</a:t>
             </a:r>
           </a:p>
         </p:txBody>
@@ -16837,7 +16908,7 @@
                   <a:srgbClr val="444444"/>
                 </a:solidFill>
               </a:rPr>
-              <a:t>22</a:t>
+              <a:t>110</a:t>
             </a:r>
           </a:p>
         </p:txBody>
@@ -16991,7 +17062,7 @@
                   <a:srgbClr val="444444"/>
                 </a:solidFill>
               </a:rPr>
-              <a:t>2</a:t>
+              <a:t>7</a:t>
             </a:r>
           </a:p>
         </p:txBody>
@@ -17068,7 +17139,7 @@
                   <a:srgbClr val="444444"/>
                 </a:solidFill>
               </a:rPr>
-              <a:t>3</a:t>
+              <a:t>15</a:t>
             </a:r>
           </a:p>
         </p:txBody>
@@ -17102,7 +17173,7 @@
                   <a:srgbClr val="666666"/>
                 </a:solidFill>
               </a:rPr>
-              <a:t>Green = BalAcc ≥ 0.75   Yellow = 0.60–0.75   Red = &lt; 0.60    Sensitivity = TPR(NAcc)  Specificity = TPR(Acc)</a:t>
+              <a:t>Green = BalAcc ≥ 0.75   Yellow = 0.60–0.75   Red = &lt; 0.60    Sensitivity = OOF TPR(NAcc)   Specificity = OOF TPR(Acc)   TN/FP/FN/TP from aggregated OOF predictions (n=132)</a:t>
             </a:r>
           </a:p>
         </p:txBody>
@@ -17239,7 +17310,7 @@
                   <a:srgbClr val="AACCFF"/>
                 </a:solidFill>
               </a:rPr>
-              <a:t>Dy28 and Dy30  ·  test set (n=27: 5 NAcc, 22 Acc)</a:t>
+              <a:t>Dy28 and Dy30  ·  OOF predictions (n=132: 22 NAcc, 110 Acc)</a:t>
             </a:r>
           </a:p>
         </p:txBody>
@@ -17273,7 +17344,7 @@
                   <a:srgbClr val="1A1A2E"/>
                 </a:solidFill>
               </a:rPr>
-              <a:t>Dy28  —  BalAcc=0.877  Sens=0.800  Spec=0.955</a:t>
+              <a:t>Dy28  —  BalAcc=0.740  Sens=0.500  Spec=1.000</a:t>
             </a:r>
           </a:p>
         </p:txBody>
@@ -17658,7 +17729,7 @@
                   <a:srgbClr val="1A1A2E"/>
                 </a:solidFill>
               </a:rPr>
-              <a:t>21</a:t>
+              <a:t>110</a:t>
             </a:r>
           </a:p>
         </p:txBody>
@@ -17769,7 +17840,7 @@
                   <a:srgbClr val="1A1A2E"/>
                 </a:solidFill>
               </a:rPr>
-              <a:t>1</a:t>
+              <a:t>0</a:t>
             </a:r>
           </a:p>
         </p:txBody>
@@ -17880,7 +17951,7 @@
                   <a:srgbClr val="1A1A2E"/>
                 </a:solidFill>
               </a:rPr>
-              <a:t>1</a:t>
+              <a:t>11</a:t>
             </a:r>
           </a:p>
         </p:txBody>
@@ -17991,7 +18062,7 @@
                   <a:srgbClr val="1A1A2E"/>
                 </a:solidFill>
               </a:rPr>
-              <a:t>4</a:t>
+              <a:t>11</a:t>
             </a:r>
           </a:p>
         </p:txBody>
@@ -18059,7 +18130,7 @@
                   <a:srgbClr val="1A1A2E"/>
                 </a:solidFill>
               </a:rPr>
-              <a:t>Dy30  —  BalAcc=0.800  Sens=0.600  Spec=1.000</a:t>
+              <a:t>Dy30  —  BalAcc=0.840  Sens=0.682  Spec=1.000</a:t>
             </a:r>
           </a:p>
         </p:txBody>
@@ -18444,7 +18515,7 @@
                   <a:srgbClr val="1A1A2E"/>
                 </a:solidFill>
               </a:rPr>
-              <a:t>22</a:t>
+              <a:t>110</a:t>
             </a:r>
           </a:p>
         </p:txBody>
@@ -18666,7 +18737,7 @@
                   <a:srgbClr val="1A1A2E"/>
                 </a:solidFill>
               </a:rPr>
-              <a:t>2</a:t>
+              <a:t>7</a:t>
             </a:r>
           </a:p>
         </p:txBody>
@@ -18777,7 +18848,7 @@
                   <a:srgbClr val="1A1A2E"/>
                 </a:solidFill>
               </a:rPr>
-              <a:t>3</a:t>
+              <a:t>15</a:t>
             </a:r>
           </a:p>
         </p:txBody>
@@ -18845,8 +18916,18 @@
                   <a:srgbClr val="444444"/>
                 </a:solidFill>
               </a:rPr>
-              <a:t>NAcc = Not Acceptable (label 1, minority class).  Green = correct prediction.  Orange = error.
-Dy28: 1 FP + 1 FN → both classes mostly captured.  Dy30: 0 FP but 2 FN → model misses 2 of 5 NAcc organoids (small test set effect).</a:t>
+              <a:t>NAcc = Not Acceptable (label 1, minority class).  Green = correct.  Orange = error.</a:t>
+            </a:r>
+          </a:p>
+          <a:p>
+            <a:pPr algn="l"/>
+            <a:r>
+              <a:rPr b="0" sz="1300">
+                <a:solidFill>
+                  <a:srgbClr val="444444"/>
+                </a:solidFill>
+              </a:rPr>
+              <a:t>Dy28: 0 FP + 11 FN.  Dy30: 0 FP + 7 FN.  OOF aggregation across 5 folds (n=132 total).</a:t>
             </a:r>
           </a:p>
         </p:txBody>
@@ -19094,7 +19175,7 @@
                   <a:srgbClr val="CCDDEE"/>
                 </a:solidFill>
               </a:rPr>
-              <a:t>Balanced accuracy = 0.50 for 6 of 11 days — model predicts all-Acceptable. No visual phenotype difference at early timepoints.</a:t>
+              <a:t>BalAcc ≤ 0.51 for Dy03–Dy15 (6 of 11 days). Model predicts all-Acceptable at early timepoints; no separable visual phenotype yet.</a:t>
             </a:r>
           </a:p>
         </p:txBody>
@@ -19205,7 +19286,7 @@
                   <a:srgbClr val="CCDDEE"/>
                 </a:solidFill>
               </a:rPr>
-              <a:t>BalAcc rises from 0.58 (Dy17) → 0.60 (Dy20) → 0.80 (Dy24) → 0.88 (Dy28) → 0.80 (Dy30). Days with BalAcc ≥ 0.75: Dy24, Dy28, Dy30.</a:t>
+              <a:t>5-fold OOF BalAcc: 0.61 (Dy17) → 0.80 (Dy20.5) → 0.85 (Dy24) → 0.74 (Dy28) → 0.84 (Dy30). Days with BalAcc ≥ 0.75: Dy20.5, Dy24, Dy30.</a:t>
             </a:r>
           </a:p>
         </p:txBody>
@@ -19282,7 +19363,7 @@
                   <a:srgbClr val="FFFFFF"/>
                 </a:solidFill>
               </a:rPr>
-              <a:t>Average balanced accuracy: 60.5%</a:t>
+              <a:t>Average balanced accuracy: 62.6%</a:t>
             </a:r>
           </a:p>
         </p:txBody>
@@ -19316,7 +19397,7 @@
                   <a:srgbClr val="CCDDEE"/>
                 </a:solidFill>
               </a:rPr>
-              <a:t>Dragged down by early flat days.  Late-day performance (Dy24–Dy30) is strong.</a:t>
+              <a:t>Overall mean (all 11 days) = 62.6%; late days Dy20.5–Dy30 average 80.9%. Corrected augmentation (fill=[178,178,178], ForegroundColorJitter) drove major improvements at Dy20.5 (+23 pp) and Dy24 (+27 pp) vs earlier runs.</a:t>
             </a:r>
           </a:p>
         </p:txBody>
@@ -19393,7 +19474,7 @@
                   <a:srgbClr val="FFFFFF"/>
                 </a:solidFill>
               </a:rPr>
-              <a:t>Small test set limits confidence</a:t>
+              <a:t>5-fold CV provides robust estimates</a:t>
             </a:r>
           </a:p>
         </p:txBody>
@@ -19427,7 +19508,7 @@
                   <a:srgbClr val="CCDDEE"/>
                 </a:solidFill>
               </a:rPr>
-              <a:t>Only 5 NAcc organoids in test set (27 total). Each misclassification changes balanced accuracy by ~10 pp.</a:t>
+              <a:t>OOF results on all 132 organoids; fold std ≤ 0.13 at late days. Augmentation reduces variance at early/mid days vs no-augmentation baseline.</a:t>
             </a:r>
           </a:p>
         </p:txBody>
@@ -19504,7 +19585,7 @@
                   <a:srgbClr val="FFFFFF"/>
                 </a:solidFill>
               </a:rPr>
-              <a:t>Next step: 5-fold CV</a:t>
+              <a:t>Multi-modal fusion adds marginal gain</a:t>
             </a:r>
           </a:p>
         </p:txBody>
@@ -19538,11 +19619,164 @@
                   <a:srgbClr val="CCDDEE"/>
                 </a:solidFill>
               </a:rPr>
-              <a:t>Fixed split results are noisy due to small test set. 5-fold stratified CV will give more reliable balanced-accuracy estimates.</a:t>
-            </a:r>
-          </a:p>
-        </p:txBody>
-      </p:sp>
+              <a:t>Morph+Image (mean-prob) reaches 0.896 at Dy30 vs image-only 0.840. Fusion reduces fold variance more than it boosts the mean. See combined_kfold_two_panel_series_idor.png for full comparison.</a:t>
+            </a:r>
+          </a:p>
+        </p:txBody>
+      </p:sp>
+    </p:spTree>
+  </p:cSld>
+  <p:clrMapOvr>
+    <a:masterClrMapping/>
+  </p:clrMapOvr>
+</p:sld>
+</file>
+
+<file path=ppt/slides/slide9.xml><?xml version="1.0" encoding="utf-8"?>
+<p:sld xmlns:a="http://schemas.openxmlformats.org/drawingml/2006/main" xmlns:p="http://schemas.openxmlformats.org/presentationml/2006/main" xmlns:r="http://schemas.openxmlformats.org/officeDocument/2006/relationships">
+  <p:cSld>
+    <p:spTree>
+      <p:nvGrpSpPr>
+        <p:cNvPr id="1" name=""/>
+        <p:cNvGrpSpPr/>
+        <p:nvPr/>
+      </p:nvGrpSpPr>
+      <p:grpSpPr/>
+      <p:sp>
+        <p:nvSpPr>
+          <p:cNvPr id="2" name="Rectangle 1"/>
+          <p:cNvSpPr/>
+          <p:nvPr/>
+        </p:nvSpPr>
+        <p:spPr>
+          <a:xfrm>
+            <a:off x="0" y="0"/>
+            <a:ext cx="12188952" cy="1005840"/>
+          </a:xfrm>
+          <a:prstGeom prst="rect">
+            <a:avLst/>
+          </a:prstGeom>
+          <a:solidFill>
+            <a:srgbClr val="1A1A2E"/>
+          </a:solidFill>
+          <a:ln>
+            <a:noFill/>
+          </a:ln>
+        </p:spPr>
+        <p:style>
+          <a:lnRef idx="1">
+            <a:schemeClr val="accent1"/>
+          </a:lnRef>
+          <a:fillRef idx="3">
+            <a:schemeClr val="accent1"/>
+          </a:fillRef>
+          <a:effectRef idx="2">
+            <a:schemeClr val="accent1"/>
+          </a:effectRef>
+          <a:fontRef idx="minor">
+            <a:schemeClr val="lt1"/>
+          </a:fontRef>
+        </p:style>
+        <p:txBody>
+          <a:bodyPr rtlCol="0" anchor="ctr"/>
+          <a:lstStyle/>
+          <a:p>
+            <a:pPr algn="ctr"/>
+          </a:p>
+        </p:txBody>
+      </p:sp>
+      <p:sp>
+        <p:nvSpPr>
+          <p:cNvPr id="3" name="TextBox 2"/>
+          <p:cNvSpPr txBox="1"/>
+          <p:nvPr/>
+        </p:nvSpPr>
+        <p:spPr>
+          <a:xfrm>
+            <a:off x="274320" y="91440"/>
+            <a:ext cx="10972800" cy="548640"/>
+          </a:xfrm>
+          <a:prstGeom prst="rect">
+            <a:avLst/>
+          </a:prstGeom>
+          <a:noFill/>
+        </p:spPr>
+        <p:txBody>
+          <a:bodyPr wrap="square">
+            <a:spAutoFit/>
+          </a:bodyPr>
+          <a:lstStyle/>
+          <a:p>
+            <a:pPr algn="l"/>
+            <a:r>
+              <a:rPr b="1" sz="2400">
+                <a:solidFill>
+                  <a:srgbClr val="FFFFFF"/>
+                </a:solidFill>
+              </a:rPr>
+              <a:t>Augmentation Ablation — With vs. Without</a:t>
+            </a:r>
+          </a:p>
+        </p:txBody>
+      </p:sp>
+      <p:sp>
+        <p:nvSpPr>
+          <p:cNvPr id="4" name="TextBox 3"/>
+          <p:cNvSpPr txBox="1"/>
+          <p:nvPr/>
+        </p:nvSpPr>
+        <p:spPr>
+          <a:xfrm>
+            <a:off x="274320" y="594360"/>
+            <a:ext cx="10972800" cy="365760"/>
+          </a:xfrm>
+          <a:prstGeom prst="rect">
+            <a:avLst/>
+          </a:prstGeom>
+          <a:noFill/>
+        </p:spPr>
+        <p:txBody>
+          <a:bodyPr wrap="square">
+            <a:spAutoFit/>
+          </a:bodyPr>
+          <a:lstStyle/>
+          <a:p>
+            <a:pPr algn="l"/>
+            <a:r>
+              <a:rPr b="0" sz="1400">
+                <a:solidFill>
+                  <a:srgbClr val="AACCFF"/>
+                </a:solidFill>
+              </a:rPr>
+              <a:t>series_idor cohort · 5-fold CV  (mean ±1 SD shading)</a:t>
+            </a:r>
+          </a:p>
+        </p:txBody>
+      </p:sp>
+      <p:pic>
+        <p:nvPicPr>
+          <p:cNvPr id="5" name="Picture 4" descr="image.png"/>
+          <p:cNvPicPr>
+            <a:picLocks noChangeAspect="1"/>
+          </p:cNvPicPr>
+          <p:nvPr/>
+        </p:nvPicPr>
+        <p:blipFill>
+          <a:blip r:embed="rId2"/>
+          <a:stretch>
+            <a:fillRect/>
+          </a:stretch>
+        </p:blipFill>
+        <p:spPr>
+          <a:xfrm>
+            <a:off x="914400" y="1097280"/>
+            <a:ext cx="10058400" cy="5303520"/>
+          </a:xfrm>
+          <a:prstGeom prst="rect">
+            <a:avLst/>
+          </a:prstGeom>
+        </p:spPr>
+      </p:pic>
     </p:spTree>
   </p:cSld>
   <p:clrMapOvr>

</xml_diff>